<commit_message>
Rebuild the app as a full-screen application with three views
Perfiles (findings strip, 24 h profile with selector, 168 h grid), Recorrido
(the seven chapters as buttons with Play) and Explorador share one selection.
Week 10 report, README, script, deck and captures updated to match.
</commit_message>
<xml_diff>
--- a/deliveries/week10/PresentationWeek10.pptx
+++ b/deliveries/week10/PresentationWeek10.pptx
@@ -685,7 +685,7 @@
           <a:p>
             <a:r>
               <a:rPr lang="en-US" dirty="0"/>
-              <a:t>Demo en vivo: cargar la página, dejar que el pico se desdibuje, bajar con → al capítulo 2.</a:t>
+              <a:t>Demo en vivo: vista Perfiles, luego pestaña Recorrido y → hasta el capítulo 2.</a:t>
             </a:r>
             <a:endParaRPr lang="en-US" dirty="0"/>
           </a:p>
@@ -2278,7 +2278,7 @@
                 <a:ea typeface="Calibri" pitchFamily="34" charset="-122"/>
                 <a:cs typeface="Calibri" pitchFamily="34" charset="-120"/>
               </a:rPr>
-              <a:t>El prototipo: un argumento, no un dashboard</a:t>
+              <a:t>El prototipo: tres vistas, una selección</a:t>
             </a:r>
             <a:endParaRPr lang="en-US" sz="2400" dirty="0"/>
           </a:p>
@@ -2326,7 +2326,7 @@
       </p:sp>
       <p:pic>
         <p:nvPicPr>
-          <p:cNvPr id="6" name="Image 0" descr="/home/claude/w10v2/capturas/01-inicio.png">    </p:cNvPr>
+          <p:cNvPr id="6" name="Image 0" descr="/home/claude/w10v2/capturas/01-perfiles.png">    </p:cNvPr>
           <p:cNvPicPr>
             <a:picLocks noChangeAspect="1"/>
           </p:cNvPicPr>
@@ -2381,7 +2381,7 @@
                 <a:ea typeface="Calibri" pitchFamily="34" charset="-122"/>
                 <a:cs typeface="Calibri" pitchFamily="34" charset="-120"/>
               </a:rPr>
-              <a:t>SIETE CAPÍTULOS + UN EXPLORADOR</a:t>
+              <a:t>PERFILES · RECORRIDO · EXPLORADOR</a:t>
             </a:r>
             <a:endParaRPr lang="en-US" sz="1100" dirty="0"/>
           </a:p>
@@ -3036,7 +3036,7 @@
                 <a:ea typeface="Calibri" pitchFamily="34" charset="-122"/>
                 <a:cs typeface="Calibri" pitchFamily="34" charset="-120"/>
               </a:rPr>
-              <a:t>Cada capítulo: una pregunta, el hallazgo como frase, el gráfico, cómo se mide, qué no demuestra, y un botón al explorador ya configurado.</a:t>
+              <a:t>Perfiles es la vista base. Recorrido lleva los siete capítulos con Play. Explorador es libre. Un clic en un hallazgo abre su capítulo; cada capítulo abre el explorador ya configurado.</a:t>
             </a:r>
             <a:endParaRPr lang="en-US" sz="1150" dirty="0"/>
           </a:p>
@@ -3214,7 +3214,7 @@
       </p:sp>
       <p:pic>
         <p:nvPicPr>
-          <p:cNvPr id="6" name="Image 0" descr="/home/claude/w10v2/capturas/06-bronx.png">    </p:cNvPr>
+          <p:cNvPr id="6" name="Image 0" descr="/home/claude/w10v2/capturas/07-bronx.png">    </p:cNvPr>
           <p:cNvPicPr>
             <a:picLocks noChangeAspect="1"/>
           </p:cNvPicPr>
@@ -4312,7 +4312,7 @@
       </p:sp>
       <p:pic>
         <p:nvPicPr>
-          <p:cNvPr id="6" name="Image 0" descr="/home/claude/w10v2/capturas/10-explorador-panel.png">    </p:cNvPr>
+          <p:cNvPr id="6" name="Image 0" descr="/home/claude/w10v2/capturas/11-explorador-panel.png">    </p:cNvPr>
           <p:cNvPicPr>
             <a:picLocks noChangeAspect="1"/>
           </p:cNvPicPr>
@@ -6636,7 +6636,7 @@
                 <a:ea typeface="Calibri" pitchFamily="34" charset="-122"/>
                 <a:cs typeface="Calibri" pitchFamily="34" charset="-120"/>
               </a:rPr>
-              <a:t>¿Narrativa + explorador es la estructura correcta?</a:t>
+              <a:t>¿Tres vistas es la estructura correcta?</a:t>
             </a:r>
             <a:endParaRPr lang="en-US" sz="1350" dirty="0"/>
           </a:p>
@@ -6678,7 +6678,7 @@
                 <a:ea typeface="Calibri" pitchFamily="34" charset="-122"/>
                 <a:cs typeface="Calibri" pitchFamily="34" charset="-120"/>
               </a:rPr>
-              <a:t>La alternativa es un solo explorador con anotaciones. ¿La narrativa guía o estorba?</a:t>
+              <a:t>Perfiles, Recorrido, Explorador. ¿Sobra alguna? ¿El recorrido debería ser la entrada por defecto?</a:t>
             </a:r>
             <a:endParaRPr lang="en-US" sz="1200" dirty="0"/>
           </a:p>

</xml_diff>

<commit_message>
Make the matrix the main view and raise the charts
Matriz: 428 stations x 168 hours or 60 months, three lenses, phase bands,
synced strips below. New charts: 24 h clocks (also as map glyphs), weekly
diverging bars, beeswarm by borough, slopegraph of asymmetry. New finding:
the week tilted (Thursday-Friday mornings lost, weekend gained). Week 10
report, README, script, deck and captures updated.
</commit_message>
<xml_diff>
--- a/deliveries/week10/PresentationWeek10.pptx
+++ b/deliveries/week10/PresentationWeek10.pptx
@@ -685,7 +685,7 @@
           <a:p>
             <a:r>
               <a:rPr lang="en-US" dirty="0"/>
-              <a:t>Demo en vivo: vista Perfiles, luego pestaña Recorrido y → hasta el capítulo 2.</a:t>
+              <a:t>Demo en vivo: Matriz, lente Qué cambió, luego pestaña Recorrido y → hasta el capítulo 2.</a:t>
             </a:r>
             <a:endParaRPr lang="en-US" dirty="0"/>
           </a:p>
@@ -2326,7 +2326,7 @@
       </p:sp>
       <p:pic>
         <p:nvPicPr>
-          <p:cNvPr id="6" name="Image 0" descr="/home/claude/w10v2/capturas/01-perfiles.png">    </p:cNvPr>
+          <p:cNvPr id="6" name="Image 0" descr="/home/claude/w10v2/capturas/02-matriz-cambio.png">    </p:cNvPr>
           <p:cNvPicPr>
             <a:picLocks noChangeAspect="1"/>
           </p:cNvPicPr>
@@ -2381,7 +2381,7 @@
                 <a:ea typeface="Calibri" pitchFamily="34" charset="-122"/>
                 <a:cs typeface="Calibri" pitchFamily="34" charset="-120"/>
               </a:rPr>
-              <a:t>PERFILES · RECORRIDO · EXPLORADOR</a:t>
+              <a:t>MATRIZ · RECORRIDO · EXPLORADOR</a:t>
             </a:r>
             <a:endParaRPr lang="en-US" sz="1100" dirty="0"/>
           </a:p>
@@ -2462,7 +2462,7 @@
         </p:nvSpPr>
         <p:spPr>
           <a:xfrm>
-            <a:off x="7772400" y="1865376"/>
+            <a:off x="7772400" y="1828800"/>
             <a:ext cx="320040" cy="320040"/>
           </a:xfrm>
           <a:prstGeom prst="rect">
@@ -2501,7 +2501,7 @@
         </p:nvSpPr>
         <p:spPr>
           <a:xfrm>
-            <a:off x="8092440" y="1865376"/>
+            <a:off x="8092440" y="1828800"/>
             <a:ext cx="3840480" cy="320040"/>
           </a:xfrm>
           <a:prstGeom prst="rect">
@@ -2540,7 +2540,7 @@
         </p:nvSpPr>
         <p:spPr>
           <a:xfrm>
-            <a:off x="7772400" y="2249424"/>
+            <a:off x="7772400" y="2176272"/>
             <a:ext cx="320040" cy="320040"/>
           </a:xfrm>
           <a:prstGeom prst="rect">
@@ -2579,7 +2579,7 @@
         </p:nvSpPr>
         <p:spPr>
           <a:xfrm>
-            <a:off x="8092440" y="2249424"/>
+            <a:off x="8092440" y="2176272"/>
             <a:ext cx="3840480" cy="320040"/>
           </a:xfrm>
           <a:prstGeom prst="rect">
@@ -2618,7 +2618,7 @@
         </p:nvSpPr>
         <p:spPr>
           <a:xfrm>
-            <a:off x="7772400" y="2633472"/>
+            <a:off x="7772400" y="2523744"/>
             <a:ext cx="320040" cy="320040"/>
           </a:xfrm>
           <a:prstGeom prst="rect">
@@ -2657,7 +2657,7 @@
         </p:nvSpPr>
         <p:spPr>
           <a:xfrm>
-            <a:off x="8092440" y="2633472"/>
+            <a:off x="8092440" y="2523744"/>
             <a:ext cx="3840480" cy="320040"/>
           </a:xfrm>
           <a:prstGeom prst="rect">
@@ -2682,6 +2682,84 @@
                 <a:ea typeface="Calibri" pitchFamily="34" charset="-122"/>
                 <a:cs typeface="Calibri" pitchFamily="34" charset="-120"/>
               </a:rPr>
+              <a:t>¿Qué días de la semana cambiaron?</a:t>
+            </a:r>
+            <a:endParaRPr lang="en-US" sz="1300" dirty="0"/>
+          </a:p>
+        </p:txBody>
+      </p:sp>
+      <p:sp>
+        <p:nvSpPr>
+          <p:cNvPr id="16" name="Text 13"/>
+          <p:cNvSpPr txBox="1"/>
+          <p:nvPr/>
+        </p:nvSpPr>
+        <p:spPr>
+          <a:xfrm>
+            <a:off x="7772400" y="2871216"/>
+            <a:ext cx="320040" cy="320040"/>
+          </a:xfrm>
+          <a:prstGeom prst="rect">
+            <a:avLst/>
+          </a:prstGeom>
+          <a:noFill/>
+          <a:ln/>
+        </p:spPr>
+        <p:txBody>
+          <a:bodyPr wrap="square" lIns="0" tIns="0" rIns="0" bIns="0" rtlCol="0" anchor="ctr"/>
+          <a:lstStyle/>
+          <a:p>
+            <a:pPr indent="0" marL="0">
+              <a:buNone/>
+            </a:pPr>
+            <a:r>
+              <a:rPr lang="en-US" sz="1300" b="1" dirty="0">
+                <a:solidFill>
+                  <a:srgbClr val="E07A16"/>
+                </a:solidFill>
+                <a:latin typeface="Calibri" pitchFamily="34" charset="0"/>
+                <a:ea typeface="Calibri" pitchFamily="34" charset="-122"/>
+                <a:cs typeface="Calibri" pitchFamily="34" charset="-120"/>
+              </a:rPr>
+              <a:t>4</a:t>
+            </a:r>
+            <a:endParaRPr lang="en-US" sz="1300" dirty="0"/>
+          </a:p>
+        </p:txBody>
+      </p:sp>
+      <p:sp>
+        <p:nvSpPr>
+          <p:cNvPr id="17" name="Text 14"/>
+          <p:cNvSpPr txBox="1"/>
+          <p:nvPr/>
+        </p:nvSpPr>
+        <p:spPr>
+          <a:xfrm>
+            <a:off x="8092440" y="2871216"/>
+            <a:ext cx="3840480" cy="320040"/>
+          </a:xfrm>
+          <a:prstGeom prst="rect">
+            <a:avLst/>
+          </a:prstGeom>
+          <a:noFill/>
+          <a:ln/>
+        </p:spPr>
+        <p:txBody>
+          <a:bodyPr wrap="square" lIns="0" tIns="0" rIns="0" bIns="0" rtlCol="0" anchor="ctr"/>
+          <a:lstStyle/>
+          <a:p>
+            <a:pPr indent="0" marL="0">
+              <a:buNone/>
+            </a:pPr>
+            <a:r>
+              <a:rPr lang="en-US" sz="1300" dirty="0">
+                <a:solidFill>
+                  <a:srgbClr val="1A1A1A"/>
+                </a:solidFill>
+                <a:latin typeface="Calibri" pitchFamily="34" charset="0"/>
+                <a:ea typeface="Calibri" pitchFamily="34" charset="-122"/>
+                <a:cs typeface="Calibri" pitchFamily="34" charset="-120"/>
+              </a:rPr>
               <a:t>¿Para qué se usa cada estación?</a:t>
             </a:r>
             <a:endParaRPr lang="en-US" sz="1300" dirty="0"/>
@@ -2690,13 +2768,13 @@
       </p:sp>
       <p:sp>
         <p:nvSpPr>
-          <p:cNvPr id="16" name="Text 13"/>
-          <p:cNvSpPr txBox="1"/>
-          <p:nvPr/>
-        </p:nvSpPr>
-        <p:spPr>
-          <a:xfrm>
-            <a:off x="7772400" y="3017520"/>
+          <p:cNvPr id="18" name="Text 15"/>
+          <p:cNvSpPr txBox="1"/>
+          <p:nvPr/>
+        </p:nvSpPr>
+        <p:spPr>
+          <a:xfrm>
+            <a:off x="7772400" y="3218688"/>
             <a:ext cx="320040" cy="320040"/>
           </a:xfrm>
           <a:prstGeom prst="rect">
@@ -2721,7 +2799,7 @@
                 <a:ea typeface="Calibri" pitchFamily="34" charset="-122"/>
                 <a:cs typeface="Calibri" pitchFamily="34" charset="-120"/>
               </a:rPr>
-              <a:t>4</a:t>
+              <a:t>5</a:t>
             </a:r>
             <a:endParaRPr lang="en-US" sz="1300" dirty="0"/>
           </a:p>
@@ -2729,13 +2807,13 @@
       </p:sp>
       <p:sp>
         <p:nvSpPr>
-          <p:cNvPr id="17" name="Text 14"/>
-          <p:cNvSpPr txBox="1"/>
-          <p:nvPr/>
-        </p:nvSpPr>
-        <p:spPr>
-          <a:xfrm>
-            <a:off x="8092440" y="3017520"/>
+          <p:cNvPr id="19" name="Text 16"/>
+          <p:cNvSpPr txBox="1"/>
+          <p:nvPr/>
+        </p:nvSpPr>
+        <p:spPr>
+          <a:xfrm>
+            <a:off x="8092440" y="3218688"/>
             <a:ext cx="3840480" cy="320040"/>
           </a:xfrm>
           <a:prstGeom prst="rect">
@@ -2768,13 +2846,13 @@
       </p:sp>
       <p:sp>
         <p:nvSpPr>
-          <p:cNvPr id="18" name="Text 15"/>
-          <p:cNvSpPr txBox="1"/>
-          <p:nvPr/>
-        </p:nvSpPr>
-        <p:spPr>
-          <a:xfrm>
-            <a:off x="7772400" y="3401568"/>
+          <p:cNvPr id="20" name="Text 17"/>
+          <p:cNvSpPr txBox="1"/>
+          <p:nvPr/>
+        </p:nvSpPr>
+        <p:spPr>
+          <a:xfrm>
+            <a:off x="7772400" y="3566160"/>
             <a:ext cx="320040" cy="320040"/>
           </a:xfrm>
           <a:prstGeom prst="rect">
@@ -2799,7 +2877,7 @@
                 <a:ea typeface="Calibri" pitchFamily="34" charset="-122"/>
                 <a:cs typeface="Calibri" pitchFamily="34" charset="-120"/>
               </a:rPr>
-              <a:t>5</a:t>
+              <a:t>6</a:t>
             </a:r>
             <a:endParaRPr lang="en-US" sz="1300" dirty="0"/>
           </a:p>
@@ -2807,13 +2885,13 @@
       </p:sp>
       <p:sp>
         <p:nvSpPr>
-          <p:cNvPr id="19" name="Text 16"/>
-          <p:cNvSpPr txBox="1"/>
-          <p:nvPr/>
-        </p:nvSpPr>
-        <p:spPr>
-          <a:xfrm>
-            <a:off x="8092440" y="3401568"/>
+          <p:cNvPr id="21" name="Text 18"/>
+          <p:cNvSpPr txBox="1"/>
+          <p:nvPr/>
+        </p:nvSpPr>
+        <p:spPr>
+          <a:xfrm>
+            <a:off x="8092440" y="3566160"/>
             <a:ext cx="3840480" cy="320040"/>
           </a:xfrm>
           <a:prstGeom prst="rect">
@@ -2846,13 +2924,13 @@
       </p:sp>
       <p:sp>
         <p:nvSpPr>
-          <p:cNvPr id="20" name="Text 17"/>
-          <p:cNvSpPr txBox="1"/>
-          <p:nvPr/>
-        </p:nvSpPr>
-        <p:spPr>
-          <a:xfrm>
-            <a:off x="7772400" y="3785616"/>
+          <p:cNvPr id="22" name="Text 19"/>
+          <p:cNvSpPr txBox="1"/>
+          <p:nvPr/>
+        </p:nvSpPr>
+        <p:spPr>
+          <a:xfrm>
+            <a:off x="7772400" y="3913632"/>
             <a:ext cx="320040" cy="320040"/>
           </a:xfrm>
           <a:prstGeom prst="rect">
@@ -2877,7 +2955,7 @@
                 <a:ea typeface="Calibri" pitchFamily="34" charset="-122"/>
                 <a:cs typeface="Calibri" pitchFamily="34" charset="-120"/>
               </a:rPr>
-              <a:t>6</a:t>
+              <a:t>7</a:t>
             </a:r>
             <a:endParaRPr lang="en-US" sz="1300" dirty="0"/>
           </a:p>
@@ -2885,13 +2963,13 @@
       </p:sp>
       <p:sp>
         <p:nvSpPr>
-          <p:cNvPr id="21" name="Text 18"/>
-          <p:cNvSpPr txBox="1"/>
-          <p:nvPr/>
-        </p:nvSpPr>
-        <p:spPr>
-          <a:xfrm>
-            <a:off x="8092440" y="3785616"/>
+          <p:cNvPr id="23" name="Text 20"/>
+          <p:cNvSpPr txBox="1"/>
+          <p:nvPr/>
+        </p:nvSpPr>
+        <p:spPr>
+          <a:xfrm>
+            <a:off x="8092440" y="3913632"/>
             <a:ext cx="3840480" cy="320040"/>
           </a:xfrm>
           <a:prstGeom prst="rect">
@@ -2924,13 +3002,13 @@
       </p:sp>
       <p:sp>
         <p:nvSpPr>
-          <p:cNvPr id="22" name="Text 19"/>
-          <p:cNvSpPr txBox="1"/>
-          <p:nvPr/>
-        </p:nvSpPr>
-        <p:spPr>
-          <a:xfrm>
-            <a:off x="7772400" y="4169664"/>
+          <p:cNvPr id="24" name="Text 21"/>
+          <p:cNvSpPr txBox="1"/>
+          <p:nvPr/>
+        </p:nvSpPr>
+        <p:spPr>
+          <a:xfrm>
+            <a:off x="7772400" y="4261104"/>
             <a:ext cx="320040" cy="320040"/>
           </a:xfrm>
           <a:prstGeom prst="rect">
@@ -2955,7 +3033,7 @@
                 <a:ea typeface="Calibri" pitchFamily="34" charset="-122"/>
                 <a:cs typeface="Calibri" pitchFamily="34" charset="-120"/>
               </a:rPr>
-              <a:t>7</a:t>
+              <a:t>8</a:t>
             </a:r>
             <a:endParaRPr lang="en-US" sz="1300" dirty="0"/>
           </a:p>
@@ -2963,13 +3041,13 @@
       </p:sp>
       <p:sp>
         <p:nvSpPr>
-          <p:cNvPr id="23" name="Text 20"/>
-          <p:cNvSpPr txBox="1"/>
-          <p:nvPr/>
-        </p:nvSpPr>
-        <p:spPr>
-          <a:xfrm>
-            <a:off x="8092440" y="4169664"/>
+          <p:cNvPr id="25" name="Text 22"/>
+          <p:cNvSpPr txBox="1"/>
+          <p:nvPr/>
+        </p:nvSpPr>
+        <p:spPr>
+          <a:xfrm>
+            <a:off x="8092440" y="4261104"/>
             <a:ext cx="3840480" cy="320040"/>
           </a:xfrm>
           <a:prstGeom prst="rect">
@@ -3002,7 +3080,7 @@
       </p:sp>
       <p:sp>
         <p:nvSpPr>
-          <p:cNvPr id="24" name="Text 21"/>
+          <p:cNvPr id="26" name="Text 23"/>
           <p:cNvSpPr txBox="1"/>
           <p:nvPr/>
         </p:nvSpPr>
@@ -3036,7 +3114,7 @@
                 <a:ea typeface="Calibri" pitchFamily="34" charset="-122"/>
                 <a:cs typeface="Calibri" pitchFamily="34" charset="-120"/>
               </a:rPr>
-              <a:t>Perfiles es la vista base. Recorrido lleva los siete capítulos con Play. Explorador es libre. Un clic en un hallazgo abre su capítulo; cada capítulo abre el explorador ya configurado.</a:t>
+              <a:t>Matriz es la vista base: 428 estaciones × 168 horas, tres lentes. Recorrido lleva los ocho capítulos con Play. Explorador es libre. Una sola selección en las tres.</a:t>
             </a:r>
             <a:endParaRPr lang="en-US" sz="1150" dirty="0"/>
           </a:p>
@@ -3044,7 +3122,7 @@
       </p:sp>
       <p:sp>
         <p:nvSpPr>
-          <p:cNvPr id="25" name="Text 22"/>
+          <p:cNvPr id="27" name="Text 24"/>
           <p:cNvSpPr txBox="1"/>
           <p:nvPr/>
         </p:nvSpPr>
@@ -3214,7 +3292,7 @@
       </p:sp>
       <p:pic>
         <p:nvPicPr>
-          <p:cNvPr id="6" name="Image 0" descr="/home/claude/w10v2/capturas/07-bronx.png">    </p:cNvPr>
+          <p:cNvPr id="6" name="Image 0" descr="/home/claude/w10v2/capturas/10-bronx.png">    </p:cNvPr>
           <p:cNvPicPr>
             <a:picLocks noChangeAspect="1"/>
           </p:cNvPicPr>
@@ -4312,7 +4390,7 @@
       </p:sp>
       <p:pic>
         <p:nvPicPr>
-          <p:cNvPr id="6" name="Image 0" descr="/home/claude/w10v2/capturas/11-explorador-panel.png">    </p:cNvPr>
+          <p:cNvPr id="6" name="Image 0" descr="/home/claude/w10v2/capturas/14-explorador-panel.png">    </p:cNvPr>
           <p:cNvPicPr>
             <a:picLocks noChangeAspect="1"/>
           </p:cNvPicPr>
@@ -6678,7 +6756,7 @@
                 <a:ea typeface="Calibri" pitchFamily="34" charset="-122"/>
                 <a:cs typeface="Calibri" pitchFamily="34" charset="-120"/>
               </a:rPr>
-              <a:t>Perfiles, Recorrido, Explorador. ¿Sobra alguna? ¿El recorrido debería ser la entrada por defecto?</a:t>
+              <a:t>Matriz, Recorrido, Explorador. ¿Sobra alguna? ¿La matriz es la entrada correcta?</a:t>
             </a:r>
             <a:endParaRPr lang="en-US" sz="1200" dirty="0"/>
           </a:p>
@@ -6823,7 +6901,7 @@
                 <a:ea typeface="Calibri" pitchFamily="34" charset="-122"/>
                 <a:cs typeface="Calibri" pitchFamily="34" charset="-120"/>
               </a:rPr>
-              <a:t>Dos de siete dicen lo que los datos no sostienen.</a:t>
+              <a:t>Dos de ocho dicen lo que los datos no sostienen.</a:t>
             </a:r>
             <a:endParaRPr lang="en-US" sz="1200" dirty="0"/>
           </a:p>

</xml_diff>

<commit_message>
Recorrido as full-screen charts; replace the explorer with a map view
Each chapter is now one composed visualization with a narrow key panel
(question, finding, what the marks mean); notes fold behind a button.
New charts: recovery ribbon with the p10-p90 band, reliability matrix of
the 37 flagged stations month by month, city-wide clock-glyph map. The
four-panel explorer is gone; the third view is the map with five lenses.
</commit_message>
<xml_diff>
--- a/deliveries/week10/PresentationWeek10.pptx
+++ b/deliveries/week10/PresentationWeek10.pptx
@@ -861,7 +861,7 @@
           <a:p>
             <a:r>
               <a:rPr lang="en-US" dirty="0"/>
-              <a:t>Demo en vivo: clic en Parkchester o Yankee Stadium. Mostrar el aviso de estacionalidad.</a:t>
+              <a:t>Demo en vivo: en el mapa, clic en Yankee Stadium. Mostrar el aviso de estacionalidad.</a:t>
             </a:r>
             <a:endParaRPr lang="en-US" dirty="0"/>
           </a:p>
@@ -2381,7 +2381,7 @@
                 <a:ea typeface="Calibri" pitchFamily="34" charset="-122"/>
                 <a:cs typeface="Calibri" pitchFamily="34" charset="-120"/>
               </a:rPr>
-              <a:t>MATRIZ · RECORRIDO · EXPLORADOR</a:t>
+              <a:t>MATRIZ · RECORRIDO · MAPA</a:t>
             </a:r>
             <a:endParaRPr lang="en-US" sz="1100" dirty="0"/>
           </a:p>
@@ -2838,7 +2838,7 @@
                 <a:ea typeface="Calibri" pitchFamily="34" charset="-122"/>
                 <a:cs typeface="Calibri" pitchFamily="34" charset="-120"/>
               </a:rPr>
-              <a:t>¿Qué cambió más: cuánto o cómo?</a:t>
+              <a:t>¿Por qué el Bronx?</a:t>
             </a:r>
             <a:endParaRPr lang="en-US" sz="1300" dirty="0"/>
           </a:p>
@@ -2916,7 +2916,7 @@
                 <a:ea typeface="Calibri" pitchFamily="34" charset="-122"/>
                 <a:cs typeface="Calibri" pitchFamily="34" charset="-120"/>
               </a:rPr>
-              <a:t>¿Por qué el Bronx?</a:t>
+              <a:t>¿Quién dejó de comprar el abono?</a:t>
             </a:r>
             <a:endParaRPr lang="en-US" sz="1300" dirty="0"/>
           </a:p>
@@ -2994,7 +2994,7 @@
                 <a:ea typeface="Calibri" pitchFamily="34" charset="-122"/>
                 <a:cs typeface="Calibri" pitchFamily="34" charset="-120"/>
               </a:rPr>
-              <a:t>¿Quién dejó de comprar el abono?</a:t>
+              <a:t>¿Qué no podemos afirmar?</a:t>
             </a:r>
             <a:endParaRPr lang="en-US" sz="1300" dirty="0"/>
           </a:p>
@@ -3003,84 +3003,6 @@
       <p:sp>
         <p:nvSpPr>
           <p:cNvPr id="24" name="Text 21"/>
-          <p:cNvSpPr txBox="1"/>
-          <p:nvPr/>
-        </p:nvSpPr>
-        <p:spPr>
-          <a:xfrm>
-            <a:off x="7772400" y="4261104"/>
-            <a:ext cx="320040" cy="320040"/>
-          </a:xfrm>
-          <a:prstGeom prst="rect">
-            <a:avLst/>
-          </a:prstGeom>
-          <a:noFill/>
-          <a:ln/>
-        </p:spPr>
-        <p:txBody>
-          <a:bodyPr wrap="square" lIns="0" tIns="0" rIns="0" bIns="0" rtlCol="0" anchor="ctr"/>
-          <a:lstStyle/>
-          <a:p>
-            <a:pPr indent="0" marL="0">
-              <a:buNone/>
-            </a:pPr>
-            <a:r>
-              <a:rPr lang="en-US" sz="1300" b="1" dirty="0">
-                <a:solidFill>
-                  <a:srgbClr val="E07A16"/>
-                </a:solidFill>
-                <a:latin typeface="Calibri" pitchFamily="34" charset="0"/>
-                <a:ea typeface="Calibri" pitchFamily="34" charset="-122"/>
-                <a:cs typeface="Calibri" pitchFamily="34" charset="-120"/>
-              </a:rPr>
-              <a:t>8</a:t>
-            </a:r>
-            <a:endParaRPr lang="en-US" sz="1300" dirty="0"/>
-          </a:p>
-        </p:txBody>
-      </p:sp>
-      <p:sp>
-        <p:nvSpPr>
-          <p:cNvPr id="25" name="Text 22"/>
-          <p:cNvSpPr txBox="1"/>
-          <p:nvPr/>
-        </p:nvSpPr>
-        <p:spPr>
-          <a:xfrm>
-            <a:off x="8092440" y="4261104"/>
-            <a:ext cx="3840480" cy="320040"/>
-          </a:xfrm>
-          <a:prstGeom prst="rect">
-            <a:avLst/>
-          </a:prstGeom>
-          <a:noFill/>
-          <a:ln/>
-        </p:spPr>
-        <p:txBody>
-          <a:bodyPr wrap="square" lIns="0" tIns="0" rIns="0" bIns="0" rtlCol="0" anchor="ctr"/>
-          <a:lstStyle/>
-          <a:p>
-            <a:pPr indent="0" marL="0">
-              <a:buNone/>
-            </a:pPr>
-            <a:r>
-              <a:rPr lang="en-US" sz="1300" dirty="0">
-                <a:solidFill>
-                  <a:srgbClr val="1A1A1A"/>
-                </a:solidFill>
-                <a:latin typeface="Calibri" pitchFamily="34" charset="0"/>
-                <a:ea typeface="Calibri" pitchFamily="34" charset="-122"/>
-                <a:cs typeface="Calibri" pitchFamily="34" charset="-120"/>
-              </a:rPr>
-              <a:t>¿Qué no podemos afirmar?</a:t>
-            </a:r>
-            <a:endParaRPr lang="en-US" sz="1300" dirty="0"/>
-          </a:p>
-        </p:txBody>
-      </p:sp>
-      <p:sp>
-        <p:nvSpPr>
-          <p:cNvPr id="26" name="Text 23"/>
           <p:cNvSpPr txBox="1"/>
           <p:nvPr/>
         </p:nvSpPr>
@@ -3114,7 +3036,7 @@
                 <a:ea typeface="Calibri" pitchFamily="34" charset="-122"/>
                 <a:cs typeface="Calibri" pitchFamily="34" charset="-120"/>
               </a:rPr>
-              <a:t>Matriz es la vista base: 428 estaciones × 168 horas, tres lentes. Recorrido lleva los ocho capítulos con Play. Explorador es libre. Una sola selección en las tres.</a:t>
+              <a:t>Matriz es la vista base: 428 estaciones × 168 horas, tres lentes. Recorrido lleva siete capítulos con Play; cada uno es un gráfico a pantalla completa. Mapa: cinco lentes, cada estación como un reloj. Una sola selección en las tres.</a:t>
             </a:r>
             <a:endParaRPr lang="en-US" sz="1150" dirty="0"/>
           </a:p>
@@ -3122,7 +3044,7 @@
       </p:sp>
       <p:sp>
         <p:nvSpPr>
-          <p:cNvPr id="27" name="Text 24"/>
+          <p:cNvPr id="25" name="Text 22"/>
           <p:cNvSpPr txBox="1"/>
           <p:nvPr/>
         </p:nvSpPr>
@@ -3292,7 +3214,7 @@
       </p:sp>
       <p:pic>
         <p:nvPicPr>
-          <p:cNvPr id="6" name="Image 0" descr="/home/claude/w10v2/capturas/10-bronx.png">    </p:cNvPr>
+          <p:cNvPr id="6" name="Image 0" descr="/home/claude/w10v2/capturas/09-bronx.png">    </p:cNvPr>
           <p:cNvPicPr>
             <a:picLocks noChangeAspect="1"/>
           </p:cNvPicPr>
@@ -4390,7 +4312,7 @@
       </p:sp>
       <p:pic>
         <p:nvPicPr>
-          <p:cNvPr id="6" name="Image 0" descr="/home/claude/w10v2/capturas/14-explorador-panel.png">    </p:cNvPr>
+          <p:cNvPr id="6" name="Image 0" descr="/home/claude/w10v2/capturas/13-mapa-panel.png">    </p:cNvPr>
           <p:cNvPicPr>
             <a:picLocks noChangeAspect="1"/>
           </p:cNvPicPr>
@@ -6756,7 +6678,7 @@
                 <a:ea typeface="Calibri" pitchFamily="34" charset="-122"/>
                 <a:cs typeface="Calibri" pitchFamily="34" charset="-120"/>
               </a:rPr>
-              <a:t>Matriz, Recorrido, Explorador. ¿Sobra alguna? ¿La matriz es la entrada correcta?</a:t>
+              <a:t>Matriz, Recorrido, Mapa. ¿Sobra alguna? ¿La matriz es la entrada correcta?</a:t>
             </a:r>
             <a:endParaRPr lang="en-US" sz="1200" dirty="0"/>
           </a:p>

</xml_diff>

<commit_message>
Drop the total record count from docs, app, deck and paper
</commit_message>
<xml_diff>
--- a/deliveries/week10/PresentationWeek10.pptx
+++ b/deliveries/week10/PresentationWeek10.pptx
@@ -2148,7 +2148,7 @@
                 <a:ea typeface="Calibri" pitchFamily="34" charset="-122"/>
                 <a:cs typeface="Calibri" pitchFamily="34" charset="-120"/>
               </a:rPr>
-              <a:t>428 estaciones · 60 meses · 120 855 568 registros</a:t>
+              <a:t>428 estaciones · 60 meses · 168 horas por estación</a:t>
             </a:r>
             <a:endParaRPr lang="en-US" sz="1500" dirty="0"/>
           </a:p>
@@ -2187,7 +2187,7 @@
                 <a:ea typeface="Calibri" pitchFamily="34" charset="-122"/>
                 <a:cs typeface="Calibri" pitchFamily="34" charset="-120"/>
               </a:rPr>
-              <a:t>Agregados del lado del servidor con la API SODA. El navegador carga 1.6 MB.</a:t>
+              <a:t>Agregados del lado del servidor con la API SODA; el dataset crudo nunca se descarga. El navegador carga 1.6 MB.</a:t>
             </a:r>
             <a:endParaRPr lang="en-US" sz="1150" dirty="0"/>
           </a:p>

</xml_diff>